<commit_message>
[Modify][MOS_PPT] change data question
</commit_message>
<xml_diff>
--- a/Data/PPT_Learn/PPT_File/12.pptx
+++ b/Data/PPT_Learn/PPT_File/12.pptx
@@ -3363,7 +3363,7 @@
           <a:p>
             <a:fld id="{51DA3061-A0A7-4F4A-8031-9CD73C4CB18A}" type="datetimeFigureOut">
               <a:rPr lang="en-US" smtClean="0"/>
-              <a:t>12/1/2025</a:t>
+              <a:t>12/9/2025</a:t>
             </a:fld>
             <a:endParaRPr lang="en-US"/>
           </a:p>
@@ -3561,7 +3561,7 @@
           <a:p>
             <a:fld id="{51DA3061-A0A7-4F4A-8031-9CD73C4CB18A}" type="datetimeFigureOut">
               <a:rPr lang="en-US" smtClean="0"/>
-              <a:t>12/1/2025</a:t>
+              <a:t>12/9/2025</a:t>
             </a:fld>
             <a:endParaRPr lang="en-US"/>
           </a:p>
@@ -3769,7 +3769,7 @@
           <a:p>
             <a:fld id="{51DA3061-A0A7-4F4A-8031-9CD73C4CB18A}" type="datetimeFigureOut">
               <a:rPr lang="en-US" smtClean="0"/>
-              <a:t>12/1/2025</a:t>
+              <a:t>12/9/2025</a:t>
             </a:fld>
             <a:endParaRPr lang="en-US"/>
           </a:p>
@@ -3967,7 +3967,7 @@
           <a:p>
             <a:fld id="{51DA3061-A0A7-4F4A-8031-9CD73C4CB18A}" type="datetimeFigureOut">
               <a:rPr lang="en-US" smtClean="0"/>
-              <a:t>12/1/2025</a:t>
+              <a:t>12/9/2025</a:t>
             </a:fld>
             <a:endParaRPr lang="en-US"/>
           </a:p>
@@ -4242,7 +4242,7 @@
           <a:p>
             <a:fld id="{51DA3061-A0A7-4F4A-8031-9CD73C4CB18A}" type="datetimeFigureOut">
               <a:rPr lang="en-US" smtClean="0"/>
-              <a:t>12/1/2025</a:t>
+              <a:t>12/9/2025</a:t>
             </a:fld>
             <a:endParaRPr lang="en-US"/>
           </a:p>
@@ -4507,7 +4507,7 @@
           <a:p>
             <a:fld id="{51DA3061-A0A7-4F4A-8031-9CD73C4CB18A}" type="datetimeFigureOut">
               <a:rPr lang="en-US" smtClean="0"/>
-              <a:t>12/1/2025</a:t>
+              <a:t>12/9/2025</a:t>
             </a:fld>
             <a:endParaRPr lang="en-US"/>
           </a:p>
@@ -4919,7 +4919,7 @@
           <a:p>
             <a:fld id="{51DA3061-A0A7-4F4A-8031-9CD73C4CB18A}" type="datetimeFigureOut">
               <a:rPr lang="en-US" smtClean="0"/>
-              <a:t>12/1/2025</a:t>
+              <a:t>12/9/2025</a:t>
             </a:fld>
             <a:endParaRPr lang="en-US"/>
           </a:p>
@@ -5060,7 +5060,7 @@
           <a:p>
             <a:fld id="{51DA3061-A0A7-4F4A-8031-9CD73C4CB18A}" type="datetimeFigureOut">
               <a:rPr lang="en-US" smtClean="0"/>
-              <a:t>12/1/2025</a:t>
+              <a:t>12/9/2025</a:t>
             </a:fld>
             <a:endParaRPr lang="en-US"/>
           </a:p>
@@ -5173,7 +5173,7 @@
           <a:p>
             <a:fld id="{51DA3061-A0A7-4F4A-8031-9CD73C4CB18A}" type="datetimeFigureOut">
               <a:rPr lang="en-US" smtClean="0"/>
-              <a:t>12/1/2025</a:t>
+              <a:t>12/9/2025</a:t>
             </a:fld>
             <a:endParaRPr lang="en-US"/>
           </a:p>
@@ -5484,7 +5484,7 @@
           <a:p>
             <a:fld id="{51DA3061-A0A7-4F4A-8031-9CD73C4CB18A}" type="datetimeFigureOut">
               <a:rPr lang="en-US" smtClean="0"/>
-              <a:t>12/1/2025</a:t>
+              <a:t>12/9/2025</a:t>
             </a:fld>
             <a:endParaRPr lang="en-US"/>
           </a:p>
@@ -5772,7 +5772,7 @@
           <a:p>
             <a:fld id="{51DA3061-A0A7-4F4A-8031-9CD73C4CB18A}" type="datetimeFigureOut">
               <a:rPr lang="en-US" smtClean="0"/>
-              <a:t>12/1/2025</a:t>
+              <a:t>12/9/2025</a:t>
             </a:fld>
             <a:endParaRPr lang="en-US"/>
           </a:p>
@@ -6016,7 +6016,7 @@
           <a:p>
             <a:fld id="{51DA3061-A0A7-4F4A-8031-9CD73C4CB18A}" type="datetimeFigureOut">
               <a:rPr lang="en-US" smtClean="0"/>
-              <a:t>12/1/2025</a:t>
+              <a:t>12/9/2025</a:t>
             </a:fld>
             <a:endParaRPr lang="en-US"/>
           </a:p>
@@ -7117,7 +7117,7 @@
             <p:ph sz="half" idx="1"/>
             <p:extLst>
               <p:ext uri="{D42A27DB-BD31-4B8C-83A1-F6EECF244321}">
-                <p14:modId xmlns:p14="http://schemas.microsoft.com/office/powerpoint/2010/main" val="902255830"/>
+                <p14:modId xmlns:p14="http://schemas.microsoft.com/office/powerpoint/2010/main" val="1870674825"/>
               </p:ext>
             </p:extLst>
           </p:nvPr>
@@ -7226,6 +7226,10 @@
                     <a:lstStyle/>
                     <a:p>
                       <a:pPr algn="ctr"/>
+                      <a:r>
+                        <a:rPr lang="en-US" b="1" dirty="0"/>
+                        <a:t>5</a:t>
+                      </a:r>
                       <a:endParaRPr lang="vi-VN" b="1" dirty="0"/>
                     </a:p>
                   </a:txBody>
@@ -7263,6 +7267,10 @@
                     <a:lstStyle/>
                     <a:p>
                       <a:pPr algn="ctr"/>
+                      <a:r>
+                        <a:rPr lang="en-US" b="1" dirty="0"/>
+                        <a:t>7</a:t>
+                      </a:r>
                       <a:endParaRPr lang="vi-VN" b="1" dirty="0"/>
                     </a:p>
                   </a:txBody>
@@ -7300,6 +7308,10 @@
                     <a:lstStyle/>
                     <a:p>
                       <a:pPr algn="ctr"/>
+                      <a:r>
+                        <a:rPr lang="en-US" b="1" dirty="0"/>
+                        <a:t>4</a:t>
+                      </a:r>
                       <a:endParaRPr lang="vi-VN" b="1" dirty="0"/>
                     </a:p>
                   </a:txBody>
@@ -7337,6 +7349,10 @@
                     <a:lstStyle/>
                     <a:p>
                       <a:pPr algn="ctr"/>
+                      <a:r>
+                        <a:rPr lang="en-US" b="1" dirty="0"/>
+                        <a:t>7</a:t>
+                      </a:r>
                       <a:endParaRPr lang="vi-VN" b="1" dirty="0"/>
                     </a:p>
                   </a:txBody>
@@ -7374,6 +7390,10 @@
                     <a:lstStyle/>
                     <a:p>
                       <a:pPr algn="ctr"/>
+                      <a:r>
+                        <a:rPr lang="en-US" b="1" dirty="0"/>
+                        <a:t>6</a:t>
+                      </a:r>
                       <a:endParaRPr lang="vi-VN" b="1" dirty="0"/>
                     </a:p>
                   </a:txBody>
@@ -7411,6 +7431,10 @@
                     <a:lstStyle/>
                     <a:p>
                       <a:pPr algn="ctr"/>
+                      <a:r>
+                        <a:rPr lang="en-US" b="1" dirty="0"/>
+                        <a:t>8</a:t>
+                      </a:r>
                       <a:endParaRPr lang="vi-VN" b="1" dirty="0"/>
                     </a:p>
                   </a:txBody>

</xml_diff>